<commit_message>
Improved presentation and fix stuck with full inventory
</commit_message>
<xml_diff>
--- a/GPP_ZombieAI_LastNameFirstName_2DAEXX.pptx
+++ b/GPP_ZombieAI_LastNameFirstName_2DAEXX.pptx
@@ -405,7 +405,7 @@
           <a:p>
             <a:fld id="{82085877-2B37-48E7-8B6D-4D4ED486130A}" type="datetimeFigureOut">
               <a:rPr lang="en-BE" smtClean="0"/>
-              <a:t>11/28/2023</a:t>
+              <a:t>05/27/2026</a:t>
             </a:fld>
             <a:endParaRPr lang="en-BE"/>
           </a:p>
@@ -605,7 +605,7 @@
           <a:p>
             <a:fld id="{82085877-2B37-48E7-8B6D-4D4ED486130A}" type="datetimeFigureOut">
               <a:rPr lang="en-BE" smtClean="0"/>
-              <a:t>11/28/2023</a:t>
+              <a:t>05/27/2026</a:t>
             </a:fld>
             <a:endParaRPr lang="en-BE"/>
           </a:p>
@@ -815,7 +815,7 @@
           <a:p>
             <a:fld id="{82085877-2B37-48E7-8B6D-4D4ED486130A}" type="datetimeFigureOut">
               <a:rPr lang="en-BE" smtClean="0"/>
-              <a:t>11/28/2023</a:t>
+              <a:t>05/27/2026</a:t>
             </a:fld>
             <a:endParaRPr lang="en-BE"/>
           </a:p>
@@ -1015,7 +1015,7 @@
           <a:p>
             <a:fld id="{82085877-2B37-48E7-8B6D-4D4ED486130A}" type="datetimeFigureOut">
               <a:rPr lang="en-BE" smtClean="0"/>
-              <a:t>11/28/2023</a:t>
+              <a:t>05/27/2026</a:t>
             </a:fld>
             <a:endParaRPr lang="en-BE"/>
           </a:p>
@@ -1291,7 +1291,7 @@
           <a:p>
             <a:fld id="{82085877-2B37-48E7-8B6D-4D4ED486130A}" type="datetimeFigureOut">
               <a:rPr lang="en-BE" smtClean="0"/>
-              <a:t>11/28/2023</a:t>
+              <a:t>05/27/2026</a:t>
             </a:fld>
             <a:endParaRPr lang="en-BE"/>
           </a:p>
@@ -1559,7 +1559,7 @@
           <a:p>
             <a:fld id="{82085877-2B37-48E7-8B6D-4D4ED486130A}" type="datetimeFigureOut">
               <a:rPr lang="en-BE" smtClean="0"/>
-              <a:t>11/28/2023</a:t>
+              <a:t>05/27/2026</a:t>
             </a:fld>
             <a:endParaRPr lang="en-BE"/>
           </a:p>
@@ -1974,7 +1974,7 @@
           <a:p>
             <a:fld id="{82085877-2B37-48E7-8B6D-4D4ED486130A}" type="datetimeFigureOut">
               <a:rPr lang="en-BE" smtClean="0"/>
-              <a:t>11/28/2023</a:t>
+              <a:t>05/27/2026</a:t>
             </a:fld>
             <a:endParaRPr lang="en-BE"/>
           </a:p>
@@ -2116,7 +2116,7 @@
           <a:p>
             <a:fld id="{82085877-2B37-48E7-8B6D-4D4ED486130A}" type="datetimeFigureOut">
               <a:rPr lang="en-BE" smtClean="0"/>
-              <a:t>11/28/2023</a:t>
+              <a:t>05/27/2026</a:t>
             </a:fld>
             <a:endParaRPr lang="en-BE"/>
           </a:p>
@@ -2229,7 +2229,7 @@
           <a:p>
             <a:fld id="{82085877-2B37-48E7-8B6D-4D4ED486130A}" type="datetimeFigureOut">
               <a:rPr lang="en-BE" smtClean="0"/>
-              <a:t>11/28/2023</a:t>
+              <a:t>05/27/2026</a:t>
             </a:fld>
             <a:endParaRPr lang="en-BE"/>
           </a:p>
@@ -2542,7 +2542,7 @@
           <a:p>
             <a:fld id="{82085877-2B37-48E7-8B6D-4D4ED486130A}" type="datetimeFigureOut">
               <a:rPr lang="en-BE" smtClean="0"/>
-              <a:t>11/28/2023</a:t>
+              <a:t>05/27/2026</a:t>
             </a:fld>
             <a:endParaRPr lang="en-BE"/>
           </a:p>
@@ -2831,7 +2831,7 @@
           <a:p>
             <a:fld id="{82085877-2B37-48E7-8B6D-4D4ED486130A}" type="datetimeFigureOut">
               <a:rPr lang="en-BE" smtClean="0"/>
-              <a:t>11/28/2023</a:t>
+              <a:t>05/27/2026</a:t>
             </a:fld>
             <a:endParaRPr lang="en-BE"/>
           </a:p>
@@ -3074,7 +3074,7 @@
           <a:p>
             <a:fld id="{82085877-2B37-48E7-8B6D-4D4ED486130A}" type="datetimeFigureOut">
               <a:rPr lang="en-BE" smtClean="0"/>
-              <a:t>11/28/2023</a:t>
+              <a:t>05/27/2026</a:t>
             </a:fld>
             <a:endParaRPr lang="en-BE"/>
           </a:p>
@@ -3477,6 +3477,14 @@
 <file path=ppt/slides/slide1.xml><?xml version="1.0" encoding="utf-8"?>
 <p:sld xmlns:a="http://schemas.openxmlformats.org/drawingml/2006/main" xmlns:r="http://schemas.openxmlformats.org/officeDocument/2006/relationships" xmlns:p="http://schemas.openxmlformats.org/presentationml/2006/main">
   <p:cSld>
+    <p:bg>
+      <p:bgPr>
+        <a:solidFill>
+          <a:schemeClr val="bg1"/>
+        </a:solidFill>
+        <a:effectLst/>
+      </p:bgPr>
+    </p:bg>
     <p:spTree>
       <p:nvGrpSpPr>
         <p:cNvPr id="1" name=""/>
@@ -3491,6 +3499,178 @@
           <a:chExt cx="0" cy="0"/>
         </a:xfrm>
       </p:grpSpPr>
+      <p:sp useBgFill="1">
+        <p:nvSpPr>
+          <p:cNvPr id="16" name="Rectangle 15">
+            <a:extLst>
+              <a:ext uri="{FF2B5EF4-FFF2-40B4-BE49-F238E27FC236}">
+                <a16:creationId xmlns:a16="http://schemas.microsoft.com/office/drawing/2014/main" id="{0671A8AE-40A1-4631-A6B8-581AFF065482}"/>
+              </a:ext>
+              <a:ext uri="{C183D7F6-B498-43B3-948B-1728B52AA6E4}">
+                <adec:decorative xmlns:adec="http://schemas.microsoft.com/office/drawing/2017/decorative" val="1"/>
+              </a:ext>
+            </a:extLst>
+          </p:cNvPr>
+          <p:cNvSpPr>
+            <a:spLocks noGrp="1" noRot="1" noChangeAspect="1" noMove="1" noResize="1" noEditPoints="1" noAdjustHandles="1" noChangeArrowheads="1" noChangeShapeType="1" noTextEdit="1"/>
+          </p:cNvSpPr>
+          <p:nvPr>
+            <p:extLst>
+              <p:ext uri="{386F3935-93C4-4BCD-93E2-E3B085C9AB24}">
+                <p16:designElem xmlns:p16="http://schemas.microsoft.com/office/powerpoint/2015/main" val="1"/>
+              </p:ext>
+            </p:extLst>
+          </p:nvPr>
+        </p:nvSpPr>
+        <p:spPr>
+          <a:xfrm>
+            <a:off x="0" y="0"/>
+            <a:ext cx="12192000" cy="6858000"/>
+          </a:xfrm>
+          <a:prstGeom prst="rect">
+            <a:avLst/>
+          </a:prstGeom>
+          <a:ln>
+            <a:noFill/>
+          </a:ln>
+        </p:spPr>
+        <p:style>
+          <a:lnRef idx="2">
+            <a:schemeClr val="accent1">
+              <a:shade val="50000"/>
+            </a:schemeClr>
+          </a:lnRef>
+          <a:fillRef idx="1">
+            <a:schemeClr val="accent1"/>
+          </a:fillRef>
+          <a:effectRef idx="0">
+            <a:schemeClr val="accent1"/>
+          </a:effectRef>
+          <a:fontRef idx="minor">
+            <a:schemeClr val="lt1"/>
+          </a:fontRef>
+        </p:style>
+        <p:txBody>
+          <a:bodyPr rtlCol="0" anchor="ctr"/>
+          <a:lstStyle/>
+          <a:p>
+            <a:pPr algn="ctr"/>
+            <a:endParaRPr lang="en-US"/>
+          </a:p>
+        </p:txBody>
+      </p:sp>
+      <p:pic>
+        <p:nvPicPr>
+          <p:cNvPr id="5" name="Picture 4" descr="Osoby w pakietach Hi-Tech">
+            <a:extLst>
+              <a:ext uri="{FF2B5EF4-FFF2-40B4-BE49-F238E27FC236}">
+                <a16:creationId xmlns:a16="http://schemas.microsoft.com/office/drawing/2014/main" id="{10D98C6E-AD62-75F6-A763-96E630A84231}"/>
+              </a:ext>
+            </a:extLst>
+          </p:cNvPr>
+          <p:cNvPicPr>
+            <a:picLocks noChangeAspect="1"/>
+          </p:cNvPicPr>
+          <p:nvPr/>
+        </p:nvPicPr>
+        <p:blipFill>
+          <a:blip r:embed="rId2"/>
+          <a:srcRect r="23298" b="9091"/>
+          <a:stretch>
+            <a:fillRect/>
+          </a:stretch>
+        </p:blipFill>
+        <p:spPr>
+          <a:xfrm>
+            <a:off x="3523488" y="10"/>
+            <a:ext cx="8668512" cy="6857990"/>
+          </a:xfrm>
+          <a:prstGeom prst="rect">
+            <a:avLst/>
+          </a:prstGeom>
+        </p:spPr>
+      </p:pic>
+      <p:sp>
+        <p:nvSpPr>
+          <p:cNvPr id="18" name="Rectangle 17">
+            <a:extLst>
+              <a:ext uri="{FF2B5EF4-FFF2-40B4-BE49-F238E27FC236}">
+                <a16:creationId xmlns:a16="http://schemas.microsoft.com/office/drawing/2014/main" id="{AB58EF07-17C2-48CF-ABB0-EEF1F17CB8F0}"/>
+              </a:ext>
+              <a:ext uri="{C183D7F6-B498-43B3-948B-1728B52AA6E4}">
+                <adec:decorative xmlns:adec="http://schemas.microsoft.com/office/drawing/2017/decorative" val="1"/>
+              </a:ext>
+            </a:extLst>
+          </p:cNvPr>
+          <p:cNvSpPr>
+            <a:spLocks noGrp="1" noRot="1" noChangeAspect="1" noMove="1" noResize="1" noEditPoints="1" noAdjustHandles="1" noChangeArrowheads="1" noChangeShapeType="1" noTextEdit="1"/>
+          </p:cNvSpPr>
+          <p:nvPr>
+            <p:extLst>
+              <p:ext uri="{386F3935-93C4-4BCD-93E2-E3B085C9AB24}">
+                <p16:designElem xmlns:p16="http://schemas.microsoft.com/office/powerpoint/2015/main" val="1"/>
+              </p:ext>
+            </p:extLst>
+          </p:nvPr>
+        </p:nvSpPr>
+        <p:spPr>
+          <a:xfrm>
+            <a:off x="3" y="0"/>
+            <a:ext cx="9339206" cy="6858000"/>
+          </a:xfrm>
+          <a:prstGeom prst="rect">
+            <a:avLst/>
+          </a:prstGeom>
+          <a:gradFill>
+            <a:gsLst>
+              <a:gs pos="58000">
+                <a:schemeClr val="tx1"/>
+              </a:gs>
+              <a:gs pos="33000">
+                <a:schemeClr val="tx1">
+                  <a:alpha val="64000"/>
+                </a:schemeClr>
+              </a:gs>
+              <a:gs pos="0">
+                <a:schemeClr val="tx1">
+                  <a:alpha val="0"/>
+                </a:schemeClr>
+              </a:gs>
+              <a:gs pos="100000">
+                <a:schemeClr val="tx1"/>
+              </a:gs>
+            </a:gsLst>
+            <a:lin ang="10800000" scaled="0"/>
+          </a:gradFill>
+          <a:ln>
+            <a:noFill/>
+          </a:ln>
+        </p:spPr>
+        <p:style>
+          <a:lnRef idx="2">
+            <a:schemeClr val="accent1">
+              <a:shade val="50000"/>
+            </a:schemeClr>
+          </a:lnRef>
+          <a:fillRef idx="1">
+            <a:schemeClr val="accent1"/>
+          </a:fillRef>
+          <a:effectRef idx="0">
+            <a:schemeClr val="accent1"/>
+          </a:effectRef>
+          <a:fontRef idx="minor">
+            <a:schemeClr val="lt1"/>
+          </a:fontRef>
+        </p:style>
+        <p:txBody>
+          <a:bodyPr rtlCol="0" anchor="ctr"/>
+          <a:lstStyle/>
+          <a:p>
+            <a:pPr algn="ctr"/>
+            <a:endParaRPr lang="en-US" dirty="0"/>
+          </a:p>
+        </p:txBody>
+      </p:sp>
       <p:sp>
         <p:nvSpPr>
           <p:cNvPr id="2" name="Title 1">
@@ -3507,68 +3687,253 @@
             <p:ph type="ctrTitle"/>
           </p:nvPr>
         </p:nvSpPr>
-        <p:spPr/>
-        <p:txBody>
-          <a:bodyPr/>
-          <a:lstStyle/>
-          <a:p>
-            <a:r>
-              <a:rPr lang="en-US"/>
-              <a:t>GPP Exam: Zombie AI</a:t>
-            </a:r>
-            <a:endParaRPr lang="en-BE"/>
-          </a:p>
-        </p:txBody>
-      </p:sp>
-      <p:sp>
-        <p:nvSpPr>
-          <p:cNvPr id="3" name="Subtitle 2">
-            <a:extLst>
-              <a:ext uri="{FF2B5EF4-FFF2-40B4-BE49-F238E27FC236}">
-                <a16:creationId xmlns:a16="http://schemas.microsoft.com/office/drawing/2014/main" id="{510651AA-5F60-4B6E-8386-AEA67C018DF4}"/>
-              </a:ext>
-            </a:extLst>
-          </p:cNvPr>
-          <p:cNvSpPr>
-            <a:spLocks noGrp="1"/>
-          </p:cNvSpPr>
-          <p:nvPr>
-            <p:ph type="subTitle" idx="1"/>
-          </p:nvPr>
-        </p:nvSpPr>
-        <p:spPr/>
-        <p:txBody>
-          <a:bodyPr/>
-          <a:lstStyle/>
-          <a:p>
-            <a:r>
-              <a:rPr lang="en-US" i="1">
+        <p:spPr>
+          <a:xfrm>
+            <a:off x="477981" y="1122363"/>
+            <a:ext cx="5437044" cy="3204134"/>
+          </a:xfrm>
+        </p:spPr>
+        <p:txBody>
+          <a:bodyPr anchor="b">
+            <a:normAutofit/>
+          </a:bodyPr>
+          <a:lstStyle/>
+          <a:p>
+            <a:pPr algn="l"/>
+            <a:r>
+              <a:rPr lang="pl-PL" dirty="0" err="1">
                 <a:solidFill>
-                  <a:schemeClr val="bg1">
-                    <a:lumMod val="75000"/>
-                  </a:schemeClr>
+                  <a:schemeClr val="bg1"/>
                 </a:solidFill>
               </a:rPr>
-              <a:t>Delete all comments after reading</a:t>
-            </a:r>
-          </a:p>
-          <a:p>
-            <a:r>
-              <a:rPr lang="en-US" i="1">
+              <a:t>Algorithms</a:t>
+            </a:r>
+            <a:r>
+              <a:rPr lang="pl-PL" dirty="0">
                 <a:solidFill>
-                  <a:schemeClr val="bg1">
-                    <a:lumMod val="75000"/>
-                  </a:schemeClr>
+                  <a:schemeClr val="bg1"/>
                 </a:solidFill>
               </a:rPr>
-              <a:t>You are not allowed to add more slides to this presentation</a:t>
-            </a:r>
-            <a:endParaRPr lang="en-BE" i="1">
+              <a:t> 2</a:t>
+            </a:r>
+            <a:r>
+              <a:rPr lang="en-US" dirty="0">
+                <a:solidFill>
+                  <a:schemeClr val="bg1"/>
+                </a:solidFill>
+              </a:rPr>
+              <a:t> Exam: Zombie AI</a:t>
+            </a:r>
+            <a:endParaRPr lang="en-BE" dirty="0">
               <a:solidFill>
-                <a:schemeClr val="bg1">
-                  <a:lumMod val="75000"/>
-                </a:schemeClr>
+                <a:schemeClr val="bg1"/>
               </a:solidFill>
+            </a:endParaRPr>
+          </a:p>
+        </p:txBody>
+      </p:sp>
+      <p:sp>
+        <p:nvSpPr>
+          <p:cNvPr id="3" name="Subtitle 2">
+            <a:extLst>
+              <a:ext uri="{FF2B5EF4-FFF2-40B4-BE49-F238E27FC236}">
+                <a16:creationId xmlns:a16="http://schemas.microsoft.com/office/drawing/2014/main" id="{510651AA-5F60-4B6E-8386-AEA67C018DF4}"/>
+              </a:ext>
+            </a:extLst>
+          </p:cNvPr>
+          <p:cNvSpPr>
+            <a:spLocks noGrp="1"/>
+          </p:cNvSpPr>
+          <p:nvPr>
+            <p:ph type="subTitle" idx="1"/>
+          </p:nvPr>
+        </p:nvSpPr>
+        <p:spPr>
+          <a:xfrm>
+            <a:off x="477980" y="4872922"/>
+            <a:ext cx="4776455" cy="1208141"/>
+          </a:xfrm>
+        </p:spPr>
+        <p:txBody>
+          <a:bodyPr>
+            <a:normAutofit/>
+          </a:bodyPr>
+          <a:lstStyle/>
+          <a:p>
+            <a:pPr algn="l"/>
+            <a:r>
+              <a:rPr lang="pl-PL" sz="4800" i="1" dirty="0">
+                <a:solidFill>
+                  <a:schemeClr val="bg1"/>
+                </a:solidFill>
+              </a:rPr>
+              <a:t>Damian Zioło</a:t>
+            </a:r>
+            <a:endParaRPr lang="en-BE" sz="4800" i="1" dirty="0">
+              <a:solidFill>
+                <a:schemeClr val="bg1"/>
+              </a:solidFill>
+            </a:endParaRPr>
+          </a:p>
+        </p:txBody>
+      </p:sp>
+      <p:sp>
+        <p:nvSpPr>
+          <p:cNvPr id="20" name="Rectangle 19">
+            <a:extLst>
+              <a:ext uri="{FF2B5EF4-FFF2-40B4-BE49-F238E27FC236}">
+                <a16:creationId xmlns:a16="http://schemas.microsoft.com/office/drawing/2014/main" id="{AF2F604E-43BE-4DC3-B983-E071523364F8}"/>
+              </a:ext>
+              <a:ext uri="{C183D7F6-B498-43B3-948B-1728B52AA6E4}">
+                <adec:decorative xmlns:adec="http://schemas.microsoft.com/office/drawing/2017/decorative" val="1"/>
+              </a:ext>
+            </a:extLst>
+          </p:cNvPr>
+          <p:cNvSpPr>
+            <a:spLocks noGrp="1" noRot="1" noChangeAspect="1" noMove="1" noResize="1" noEditPoints="1" noAdjustHandles="1" noChangeArrowheads="1" noChangeShapeType="1" noTextEdit="1"/>
+          </p:cNvSpPr>
+          <p:nvPr>
+            <p:extLst>
+              <p:ext uri="{386F3935-93C4-4BCD-93E2-E3B085C9AB24}">
+                <p16:designElem xmlns:p16="http://schemas.microsoft.com/office/powerpoint/2015/main" val="1"/>
+              </p:ext>
+            </p:extLst>
+          </p:nvPr>
+        </p:nvSpPr>
+        <p:spPr>
+          <a:xfrm rot="5400000">
+            <a:off x="759921" y="346791"/>
+            <a:ext cx="146304" cy="704088"/>
+          </a:xfrm>
+          <a:prstGeom prst="rect">
+            <a:avLst/>
+          </a:prstGeom>
+          <a:solidFill>
+            <a:schemeClr val="accent2"/>
+          </a:solidFill>
+          <a:ln>
+            <a:noFill/>
+          </a:ln>
+        </p:spPr>
+        <p:style>
+          <a:lnRef idx="2">
+            <a:schemeClr val="accent1">
+              <a:shade val="50000"/>
+            </a:schemeClr>
+          </a:lnRef>
+          <a:fillRef idx="1">
+            <a:schemeClr val="accent1"/>
+          </a:fillRef>
+          <a:effectRef idx="0">
+            <a:schemeClr val="accent1"/>
+          </a:effectRef>
+          <a:fontRef idx="minor">
+            <a:schemeClr val="lt1"/>
+          </a:fontRef>
+        </p:style>
+        <p:txBody>
+          <a:bodyPr rtlCol="0" anchor="ctr"/>
+          <a:lstStyle/>
+          <a:p>
+            <a:pPr algn="ctr"/>
+            <a:endParaRPr lang="en-US">
+              <a:solidFill>
+                <a:prstClr val="white"/>
+              </a:solidFill>
+              <a:latin typeface="Calibri" panose="020F0502020204030204"/>
+            </a:endParaRPr>
+          </a:p>
+        </p:txBody>
+      </p:sp>
+      <p:sp>
+        <p:nvSpPr>
+          <p:cNvPr id="22" name="Rectangle 21">
+            <a:extLst>
+              <a:ext uri="{FF2B5EF4-FFF2-40B4-BE49-F238E27FC236}">
+                <a16:creationId xmlns:a16="http://schemas.microsoft.com/office/drawing/2014/main" id="{08C9B587-E65E-4B52-B37C-ABEBB6E87928}"/>
+              </a:ext>
+              <a:ext uri="{C183D7F6-B498-43B3-948B-1728B52AA6E4}">
+                <adec:decorative xmlns:adec="http://schemas.microsoft.com/office/drawing/2017/decorative" val="1"/>
+              </a:ext>
+            </a:extLst>
+          </p:cNvPr>
+          <p:cNvSpPr>
+            <a:spLocks noGrp="1" noRot="1" noChangeAspect="1" noMove="1" noResize="1" noEditPoints="1" noAdjustHandles="1" noChangeArrowheads="1" noChangeShapeType="1" noTextEdit="1"/>
+          </p:cNvSpPr>
+          <p:nvPr>
+            <p:extLst>
+              <p:ext uri="{386F3935-93C4-4BCD-93E2-E3B085C9AB24}">
+                <p16:designElem xmlns:p16="http://schemas.microsoft.com/office/powerpoint/2015/main" val="1"/>
+              </p:ext>
+            </p:extLst>
+          </p:nvPr>
+        </p:nvSpPr>
+        <p:spPr>
+          <a:xfrm>
+            <a:off x="481029" y="4546920"/>
+            <a:ext cx="3977640" cy="18288"/>
+          </a:xfrm>
+          <a:prstGeom prst="rect">
+            <a:avLst/>
+          </a:prstGeom>
+          <a:solidFill>
+            <a:schemeClr val="tx1"/>
+          </a:solidFill>
+          <a:ln w="3175">
+            <a:noFill/>
+          </a:ln>
+          <a:effectLst/>
+        </p:spPr>
+        <p:style>
+          <a:lnRef idx="2">
+            <a:schemeClr val="accent1">
+              <a:shade val="50000"/>
+            </a:schemeClr>
+          </a:lnRef>
+          <a:fillRef idx="1">
+            <a:schemeClr val="accent1"/>
+          </a:fillRef>
+          <a:effectRef idx="0">
+            <a:schemeClr val="accent1"/>
+          </a:effectRef>
+          <a:fontRef idx="minor">
+            <a:schemeClr val="lt1"/>
+          </a:fontRef>
+        </p:style>
+        <p:txBody>
+          <a:bodyPr rtlCol="0" anchor="ctr"/>
+          <a:lstStyle/>
+          <a:p>
+            <a:pPr marL="0" marR="0" lvl="0" indent="0" algn="ctr" defTabSz="914400" rtl="0" eaLnBrk="1" fontAlgn="auto" latinLnBrk="0" hangingPunct="1">
+              <a:lnSpc>
+                <a:spcPct val="100000"/>
+              </a:lnSpc>
+              <a:spcBef>
+                <a:spcPts val="0"/>
+              </a:spcBef>
+              <a:spcAft>
+                <a:spcPts val="0"/>
+              </a:spcAft>
+              <a:buClrTx/>
+              <a:buSzTx/>
+              <a:buFontTx/>
+              <a:buNone/>
+              <a:tabLst/>
+              <a:defRPr/>
+            </a:pPr>
+            <a:endParaRPr kumimoji="0" lang="en-US" sz="1800" b="0" i="0" u="none" strike="noStrike" kern="1200" cap="none" spc="0" normalizeH="0" baseline="0" noProof="0">
+              <a:ln>
+                <a:noFill/>
+              </a:ln>
+              <a:solidFill>
+                <a:prstClr val="white"/>
+              </a:solidFill>
+              <a:effectLst/>
+              <a:uLnTx/>
+              <a:uFillTx/>
+              <a:latin typeface="Calibri" panose="020F0502020204030204"/>
+              <a:ea typeface="+mn-ea"/>
+              <a:cs typeface="+mn-cs"/>
             </a:endParaRPr>
           </a:p>
         </p:txBody>
@@ -3583,6 +3948,145 @@
   <p:clrMapOvr>
     <a:masterClrMapping/>
   </p:clrMapOvr>
+  <p:timing>
+    <p:tnLst>
+      <p:par>
+        <p:cTn id="1" dur="indefinite" restart="never" nodeType="tmRoot">
+          <p:childTnLst>
+            <p:seq concurrent="1" nextAc="seek">
+              <p:cTn id="2" dur="indefinite" nodeType="mainSeq">
+                <p:childTnLst>
+                  <p:par>
+                    <p:cTn id="3" fill="hold">
+                      <p:stCondLst>
+                        <p:cond delay="indefinite"/>
+                        <p:cond evt="onBegin" delay="0">
+                          <p:tn val="2"/>
+                        </p:cond>
+                      </p:stCondLst>
+                      <p:childTnLst>
+                        <p:par>
+                          <p:cTn id="4" fill="hold">
+                            <p:stCondLst>
+                              <p:cond delay="0"/>
+                            </p:stCondLst>
+                            <p:childTnLst>
+                              <p:par>
+                                <p:cTn id="5" presetID="10" presetClass="entr" presetSubtype="0" fill="hold" grpId="0" nodeType="withEffect">
+                                  <p:stCondLst>
+                                    <p:cond delay="1000"/>
+                                  </p:stCondLst>
+                                  <p:iterate type="lt">
+                                    <p:tmPct val="10000"/>
+                                  </p:iterate>
+                                  <p:childTnLst>
+                                    <p:set>
+                                      <p:cBhvr>
+                                        <p:cTn id="6" dur="1" fill="hold">
+                                          <p:stCondLst>
+                                            <p:cond delay="0"/>
+                                          </p:stCondLst>
+                                        </p:cTn>
+                                        <p:tgtEl>
+                                          <p:spTgt spid="2"/>
+                                        </p:tgtEl>
+                                        <p:attrNameLst>
+                                          <p:attrName>style.visibility</p:attrName>
+                                        </p:attrNameLst>
+                                      </p:cBhvr>
+                                      <p:to>
+                                        <p:strVal val="visible"/>
+                                      </p:to>
+                                    </p:set>
+                                    <p:animEffect transition="in" filter="fade">
+                                      <p:cBhvr>
+                                        <p:cTn id="7" dur="400"/>
+                                        <p:tgtEl>
+                                          <p:spTgt spid="2"/>
+                                        </p:tgtEl>
+                                      </p:cBhvr>
+                                    </p:animEffect>
+                                  </p:childTnLst>
+                                </p:cTn>
+                              </p:par>
+                              <p:par>
+                                <p:cTn id="8" presetID="10" presetClass="entr" presetSubtype="0" fill="hold" grpId="0" nodeType="withEffect">
+                                  <p:stCondLst>
+                                    <p:cond delay="2000"/>
+                                  </p:stCondLst>
+                                  <p:iterate type="lt">
+                                    <p:tmPct val="10000"/>
+                                  </p:iterate>
+                                  <p:childTnLst>
+                                    <p:set>
+                                      <p:cBhvr>
+                                        <p:cTn id="9" dur="1" fill="hold">
+                                          <p:stCondLst>
+                                            <p:cond delay="0"/>
+                                          </p:stCondLst>
+                                        </p:cTn>
+                                        <p:tgtEl>
+                                          <p:spTgt spid="3">
+                                            <p:txEl>
+                                              <p:pRg st="0" end="0"/>
+                                            </p:txEl>
+                                          </p:spTgt>
+                                        </p:tgtEl>
+                                        <p:attrNameLst>
+                                          <p:attrName>style.visibility</p:attrName>
+                                        </p:attrNameLst>
+                                      </p:cBhvr>
+                                      <p:to>
+                                        <p:strVal val="visible"/>
+                                      </p:to>
+                                    </p:set>
+                                    <p:animEffect transition="in" filter="fade">
+                                      <p:cBhvr>
+                                        <p:cTn id="10" dur="400"/>
+                                        <p:tgtEl>
+                                          <p:spTgt spid="3">
+                                            <p:txEl>
+                                              <p:pRg st="0" end="0"/>
+                                            </p:txEl>
+                                          </p:spTgt>
+                                        </p:tgtEl>
+                                      </p:cBhvr>
+                                    </p:animEffect>
+                                  </p:childTnLst>
+                                </p:cTn>
+                              </p:par>
+                            </p:childTnLst>
+                          </p:cTn>
+                        </p:par>
+                      </p:childTnLst>
+                    </p:cTn>
+                  </p:par>
+                </p:childTnLst>
+              </p:cTn>
+              <p:prevCondLst>
+                <p:cond evt="onPrev" delay="0">
+                  <p:tgtEl>
+                    <p:sldTgt/>
+                  </p:tgtEl>
+                </p:cond>
+              </p:prevCondLst>
+              <p:nextCondLst>
+                <p:cond evt="onNext" delay="0">
+                  <p:tgtEl>
+                    <p:sldTgt/>
+                  </p:tgtEl>
+                </p:cond>
+              </p:nextCondLst>
+            </p:seq>
+          </p:childTnLst>
+        </p:cTn>
+      </p:par>
+    </p:tnLst>
+    <p:bldLst>
+      <p:bldP spid="2" grpId="0"/>
+      <p:bldP spid="3" grpId="0" build="p"/>
+    </p:bldLst>
+  </p:timing>
 </p:sld>
 </file>
 
@@ -3619,16 +4123,24 @@
             <p:ph type="title"/>
           </p:nvPr>
         </p:nvSpPr>
-        <p:spPr/>
-        <p:txBody>
-          <a:bodyPr/>
-          <a:lstStyle/>
-          <a:p>
-            <a:r>
-              <a:rPr lang="en-US"/>
+        <p:spPr>
+          <a:xfrm>
+            <a:off x="705461" y="-201168"/>
+            <a:ext cx="10515600" cy="1325563"/>
+          </a:xfrm>
+        </p:spPr>
+        <p:txBody>
+          <a:bodyPr>
+            <a:normAutofit/>
+          </a:bodyPr>
+          <a:lstStyle/>
+          <a:p>
+            <a:pPr algn="ctr"/>
+            <a:r>
+              <a:rPr lang="en-US" sz="5400" dirty="0"/>
               <a:t>Decision Making</a:t>
             </a:r>
-            <a:endParaRPr lang="en-BE"/>
+            <a:endParaRPr lang="en-BE" sz="5400" dirty="0"/>
           </a:p>
         </p:txBody>
       </p:sp>
@@ -3686,6 +4198,36 @@
           </a:p>
         </p:txBody>
       </p:sp>
+      <p:pic>
+        <p:nvPicPr>
+          <p:cNvPr id="7" name="Obraz 6">
+            <a:extLst>
+              <a:ext uri="{FF2B5EF4-FFF2-40B4-BE49-F238E27FC236}">
+                <a16:creationId xmlns:a16="http://schemas.microsoft.com/office/drawing/2014/main" id="{49AAD28B-CEC2-5EB7-06EB-06B15893DB03}"/>
+              </a:ext>
+            </a:extLst>
+          </p:cNvPr>
+          <p:cNvPicPr>
+            <a:picLocks noChangeAspect="1"/>
+          </p:cNvPicPr>
+          <p:nvPr/>
+        </p:nvPicPr>
+        <p:blipFill>
+          <a:blip r:embed="rId2"/>
+          <a:stretch>
+            <a:fillRect/>
+          </a:stretch>
+        </p:blipFill>
+        <p:spPr>
+          <a:xfrm>
+            <a:off x="1153946" y="809625"/>
+            <a:ext cx="9618630" cy="5756275"/>
+          </a:xfrm>
+          <a:prstGeom prst="rect">
+            <a:avLst/>
+          </a:prstGeom>
+        </p:spPr>
+      </p:pic>
     </p:spTree>
     <p:extLst>
       <p:ext uri="{BB962C8B-B14F-4D97-AF65-F5344CB8AC3E}">
@@ -3738,10 +4280,10 @@
           <a:lstStyle/>
           <a:p>
             <a:r>
-              <a:rPr lang="en-US"/>
+              <a:rPr lang="en-US" dirty="0"/>
               <a:t>Enemy handling</a:t>
             </a:r>
-            <a:endParaRPr lang="en-BE"/>
+            <a:endParaRPr lang="en-BE" dirty="0"/>
           </a:p>
         </p:txBody>
       </p:sp>
@@ -3761,41 +4303,31 @@
             <p:ph idx="1"/>
           </p:nvPr>
         </p:nvSpPr>
-        <p:spPr/>
-        <p:txBody>
-          <a:bodyPr/>
-          <a:lstStyle/>
-          <a:p>
-            <a:r>
-              <a:rPr lang="en-US" i="1">
-                <a:solidFill>
-                  <a:schemeClr val="bg1">
-                    <a:lumMod val="75000"/>
-                  </a:schemeClr>
-                </a:solidFill>
-              </a:rPr>
-              <a:t>How does your agent deal with enemies (aiming, shooting, item usage, avoidance, hiding, usage of sprint, …)?</a:t>
-            </a:r>
-            <a:endParaRPr lang="en-BE" i="1">
-              <a:solidFill>
-                <a:schemeClr val="bg1">
-                  <a:lumMod val="75000"/>
-                </a:schemeClr>
-              </a:solidFill>
-            </a:endParaRPr>
-          </a:p>
-          <a:p>
-            <a:r>
-              <a:rPr lang="en-US" i="1">
-                <a:solidFill>
-                  <a:schemeClr val="bg1">
-                    <a:lumMod val="75000"/>
-                  </a:schemeClr>
-                </a:solidFill>
-              </a:rPr>
-              <a:t>USE IMAGES/GIFS</a:t>
-            </a:r>
-            <a:endParaRPr lang="en-BE"/>
+        <p:spPr>
+          <a:xfrm>
+            <a:off x="563880" y="1807337"/>
+            <a:ext cx="5836920" cy="4351338"/>
+          </a:xfrm>
+        </p:spPr>
+        <p:txBody>
+          <a:bodyPr>
+            <a:normAutofit lnSpcReduction="10000"/>
+          </a:bodyPr>
+          <a:lstStyle/>
+          <a:p>
+            <a:r>
+              <a:rPr lang="en-US" dirty="0"/>
+              <a:t>The agent remembers nearby zombies and calculates a flee direction away from them. If it has a weapon, it rotates toward the closest zombie while still moving away, allowing it to “kite” enemies. It only shoots when it is facing the zombie correctly and the weapon has ammo</a:t>
+            </a:r>
+            <a:r>
+              <a:rPr lang="pl-PL" dirty="0"/>
+              <a:t>.</a:t>
+            </a:r>
+            <a:r>
+              <a:rPr lang="en-US" dirty="0"/>
+              <a:t> If the agent is damaged from behind, it can create a temporary “ghost zombie” memory behind itself to react to unseen threats</a:t>
+            </a:r>
+            <a:endParaRPr lang="en-BE" dirty="0"/>
           </a:p>
         </p:txBody>
       </p:sp>
@@ -4544,6 +5076,21 @@
 </file>
 
 <file path=customXml/item2.xml><?xml version="1.0" encoding="utf-8"?>
+<p:properties xmlns:p="http://schemas.microsoft.com/office/2006/metadata/properties" xmlns:xsi="http://www.w3.org/2001/XMLSchema-instance" xmlns:pc="http://schemas.microsoft.com/office/infopath/2007/PartnerControls">
+  <documentManagement>
+    <IconOverlay xmlns="http://schemas.microsoft.com/sharepoint/v4" xsi:nil="true"/>
+    <TaxCatchAll xmlns="128482ec-0431-40d5-ab26-89ea2a4f3ccd" xsi:nil="true"/>
+    <m99485b88215436a82099f8287cba0b0 xmlns="128482ec-0431-40d5-ab26-89ea2a4f3ccd">
+      <Terms xmlns="http://schemas.microsoft.com/office/infopath/2007/PartnerControls"/>
+    </m99485b88215436a82099f8287cba0b0>
+    <lcf76f155ced4ddcb4097134ff3c332f xmlns="60eb0cf4-ae2a-4762-800a-cb593b869ecb">
+      <Terms xmlns="http://schemas.microsoft.com/office/infopath/2007/PartnerControls"/>
+    </lcf76f155ced4ddcb4097134ff3c332f>
+  </documentManagement>
+</p:properties>
+</file>
+
+<file path=customXml/item3.xml><?xml version="1.0" encoding="utf-8"?>
 <ct:contentTypeSchema xmlns:ct="http://schemas.microsoft.com/office/2006/metadata/contentType" xmlns:ma="http://schemas.microsoft.com/office/2006/metadata/properties/metaAttributes" ct:_="" ma:_="" ma:contentTypeName="Document" ma:contentTypeID="0x010100723942CCEB3A674D8F1F6472CCEFB38E" ma:contentTypeVersion="11" ma:contentTypeDescription="Create a new document." ma:contentTypeScope="" ma:versionID="e4de40d148e029d40e3aaddc8bf68a5e">
   <xsd:schema xmlns:xsd="http://www.w3.org/2001/XMLSchema" xmlns:xs="http://www.w3.org/2001/XMLSchema" xmlns:p="http://schemas.microsoft.com/office/2006/metadata/properties" xmlns:ns2="128482ec-0431-40d5-ab26-89ea2a4f3ccd" xmlns:ns3="60eb0cf4-ae2a-4762-800a-cb593b869ecb" xmlns:ns4="http://schemas.microsoft.com/sharepoint/v4" xmlns:ns5="a2e691a9-fcfc-4d85-a390-1894fe98bd9e" targetNamespace="http://schemas.microsoft.com/office/2006/metadata/properties" ma:root="true" ma:fieldsID="fce8e8bd091658f3fe51b22d57dec109" ns2:_="" ns3:_="" ns4:_="" ns5:_="">
     <xsd:import namespace="128482ec-0431-40d5-ab26-89ea2a4f3ccd"/>
@@ -4816,21 +5363,6 @@
 </ct:contentTypeSchema>
 </file>
 
-<file path=customXml/item3.xml><?xml version="1.0" encoding="utf-8"?>
-<p:properties xmlns:p="http://schemas.microsoft.com/office/2006/metadata/properties" xmlns:xsi="http://www.w3.org/2001/XMLSchema-instance" xmlns:pc="http://schemas.microsoft.com/office/infopath/2007/PartnerControls">
-  <documentManagement>
-    <IconOverlay xmlns="http://schemas.microsoft.com/sharepoint/v4" xsi:nil="true"/>
-    <TaxCatchAll xmlns="128482ec-0431-40d5-ab26-89ea2a4f3ccd" xsi:nil="true"/>
-    <m99485b88215436a82099f8287cba0b0 xmlns="128482ec-0431-40d5-ab26-89ea2a4f3ccd">
-      <Terms xmlns="http://schemas.microsoft.com/office/infopath/2007/PartnerControls"/>
-    </m99485b88215436a82099f8287cba0b0>
-    <lcf76f155ced4ddcb4097134ff3c332f xmlns="60eb0cf4-ae2a-4762-800a-cb593b869ecb">
-      <Terms xmlns="http://schemas.microsoft.com/office/infopath/2007/PartnerControls"/>
-    </lcf76f155ced4ddcb4097134ff3c332f>
-  </documentManagement>
-</p:properties>
-</file>
-
 <file path=customXml/itemProps1.xml><?xml version="1.0" encoding="utf-8"?>
 <ds:datastoreItem xmlns:ds="http://schemas.openxmlformats.org/officeDocument/2006/customXml" ds:itemID="{AF8EC6D1-CB19-4400-AD0A-0C75CD884AEA}">
   <ds:schemaRefs>
@@ -4840,6 +5372,18 @@
 </file>
 
 <file path=customXml/itemProps2.xml><?xml version="1.0" encoding="utf-8"?>
+<ds:datastoreItem xmlns:ds="http://schemas.openxmlformats.org/officeDocument/2006/customXml" ds:itemID="{B743389A-7EE0-4951-8919-E91DD69E3687}">
+  <ds:schemaRefs>
+    <ds:schemaRef ds:uri="128482ec-0431-40d5-ab26-89ea2a4f3ccd"/>
+    <ds:schemaRef ds:uri="http://schemas.microsoft.com/office/2006/metadata/properties"/>
+    <ds:schemaRef ds:uri="http://schemas.microsoft.com/office/infopath/2007/PartnerControls"/>
+    <ds:schemaRef ds:uri="http://schemas.microsoft.com/sharepoint/v4"/>
+    <ds:schemaRef ds:uri="60eb0cf4-ae2a-4762-800a-cb593b869ecb"/>
+  </ds:schemaRefs>
+</ds:datastoreItem>
+</file>
+
+<file path=customXml/itemProps3.xml><?xml version="1.0" encoding="utf-8"?>
 <ds:datastoreItem xmlns:ds="http://schemas.openxmlformats.org/officeDocument/2006/customXml" ds:itemID="{D7B8C5DE-3345-4025-A942-C5AA68E55545}">
   <ds:schemaRefs>
     <ds:schemaRef ds:uri="http://schemas.microsoft.com/office/2006/metadata/contentType"/>
@@ -4858,16 +5402,4 @@
     <ds:schemaRef ds:uri="http://schemas.microsoft.com/internal/obd"/>
   </ds:schemaRefs>
 </ds:datastoreItem>
-</file>
-
-<file path=customXml/itemProps3.xml><?xml version="1.0" encoding="utf-8"?>
-<ds:datastoreItem xmlns:ds="http://schemas.openxmlformats.org/officeDocument/2006/customXml" ds:itemID="{B743389A-7EE0-4951-8919-E91DD69E3687}">
-  <ds:schemaRefs>
-    <ds:schemaRef ds:uri="128482ec-0431-40d5-ab26-89ea2a4f3ccd"/>
-    <ds:schemaRef ds:uri="http://schemas.microsoft.com/office/2006/metadata/properties"/>
-    <ds:schemaRef ds:uri="http://schemas.microsoft.com/office/infopath/2007/PartnerControls"/>
-    <ds:schemaRef ds:uri="http://schemas.microsoft.com/sharepoint/v4"/>
-    <ds:schemaRef ds:uri="60eb0cf4-ae2a-4762-800a-cb593b869ecb"/>
-  </ds:schemaRefs>
-</ds:datastoreItem>
 </file>
</xml_diff>